<commit_message>
docs: update store listing screenshots
</commit_message>
<xml_diff>
--- a/docs/distribution/store/listing/design-source/en-US/clipsave-store-listing-design-source.pptx
+++ b/docs/distribution/store/listing/design-source/en-US/clipsave-store-listing-design-source.pptx
@@ -267,7 +267,7 @@
           <a:p>
             <a:fld id="{46D3C7F6-BF65-453D-9C87-5BA16A0A8437}" type="datetimeFigureOut">
               <a:rPr kumimoji="1" lang="ja-JP" altLang="en-US" smtClean="0"/>
-              <a:t>2026/3/8</a:t>
+              <a:t>2026/3/12</a:t>
             </a:fld>
             <a:endParaRPr kumimoji="1" lang="ja-JP" altLang="en-US"/>
           </a:p>
@@ -497,7 +497,7 @@
           <a:p>
             <a:fld id="{46D3C7F6-BF65-453D-9C87-5BA16A0A8437}" type="datetimeFigureOut">
               <a:rPr kumimoji="1" lang="ja-JP" altLang="en-US" smtClean="0"/>
-              <a:t>2026/3/8</a:t>
+              <a:t>2026/3/12</a:t>
             </a:fld>
             <a:endParaRPr kumimoji="1" lang="ja-JP" altLang="en-US"/>
           </a:p>
@@ -737,7 +737,7 @@
           <a:p>
             <a:fld id="{46D3C7F6-BF65-453D-9C87-5BA16A0A8437}" type="datetimeFigureOut">
               <a:rPr kumimoji="1" lang="ja-JP" altLang="en-US" smtClean="0"/>
-              <a:t>2026/3/8</a:t>
+              <a:t>2026/3/12</a:t>
             </a:fld>
             <a:endParaRPr kumimoji="1" lang="ja-JP" altLang="en-US"/>
           </a:p>
@@ -967,7 +967,7 @@
           <a:p>
             <a:fld id="{46D3C7F6-BF65-453D-9C87-5BA16A0A8437}" type="datetimeFigureOut">
               <a:rPr kumimoji="1" lang="ja-JP" altLang="en-US" smtClean="0"/>
-              <a:t>2026/3/8</a:t>
+              <a:t>2026/3/12</a:t>
             </a:fld>
             <a:endParaRPr kumimoji="1" lang="ja-JP" altLang="en-US"/>
           </a:p>
@@ -1242,7 +1242,7 @@
           <a:p>
             <a:fld id="{46D3C7F6-BF65-453D-9C87-5BA16A0A8437}" type="datetimeFigureOut">
               <a:rPr kumimoji="1" lang="ja-JP" altLang="en-US" smtClean="0"/>
-              <a:t>2026/3/8</a:t>
+              <a:t>2026/3/12</a:t>
             </a:fld>
             <a:endParaRPr kumimoji="1" lang="ja-JP" altLang="en-US"/>
           </a:p>
@@ -1571,7 +1571,7 @@
           <a:p>
             <a:fld id="{46D3C7F6-BF65-453D-9C87-5BA16A0A8437}" type="datetimeFigureOut">
               <a:rPr kumimoji="1" lang="ja-JP" altLang="en-US" smtClean="0"/>
-              <a:t>2026/3/8</a:t>
+              <a:t>2026/3/12</a:t>
             </a:fld>
             <a:endParaRPr kumimoji="1" lang="ja-JP" altLang="en-US"/>
           </a:p>
@@ -2047,7 +2047,7 @@
           <a:p>
             <a:fld id="{46D3C7F6-BF65-453D-9C87-5BA16A0A8437}" type="datetimeFigureOut">
               <a:rPr kumimoji="1" lang="ja-JP" altLang="en-US" smtClean="0"/>
-              <a:t>2026/3/8</a:t>
+              <a:t>2026/3/12</a:t>
             </a:fld>
             <a:endParaRPr kumimoji="1" lang="ja-JP" altLang="en-US"/>
           </a:p>
@@ -2188,7 +2188,7 @@
           <a:p>
             <a:fld id="{46D3C7F6-BF65-453D-9C87-5BA16A0A8437}" type="datetimeFigureOut">
               <a:rPr kumimoji="1" lang="ja-JP" altLang="en-US" smtClean="0"/>
-              <a:t>2026/3/8</a:t>
+              <a:t>2026/3/12</a:t>
             </a:fld>
             <a:endParaRPr kumimoji="1" lang="ja-JP" altLang="en-US"/>
           </a:p>
@@ -2301,7 +2301,7 @@
           <a:p>
             <a:fld id="{46D3C7F6-BF65-453D-9C87-5BA16A0A8437}" type="datetimeFigureOut">
               <a:rPr kumimoji="1" lang="ja-JP" altLang="en-US" smtClean="0"/>
-              <a:t>2026/3/8</a:t>
+              <a:t>2026/3/12</a:t>
             </a:fld>
             <a:endParaRPr kumimoji="1" lang="ja-JP" altLang="en-US"/>
           </a:p>
@@ -2644,7 +2644,7 @@
           <a:p>
             <a:fld id="{46D3C7F6-BF65-453D-9C87-5BA16A0A8437}" type="datetimeFigureOut">
               <a:rPr kumimoji="1" lang="ja-JP" altLang="en-US" smtClean="0"/>
-              <a:t>2026/3/8</a:t>
+              <a:t>2026/3/12</a:t>
             </a:fld>
             <a:endParaRPr kumimoji="1" lang="ja-JP" altLang="en-US"/>
           </a:p>
@@ -2932,7 +2932,7 @@
           <a:p>
             <a:fld id="{46D3C7F6-BF65-453D-9C87-5BA16A0A8437}" type="datetimeFigureOut">
               <a:rPr kumimoji="1" lang="ja-JP" altLang="en-US" smtClean="0"/>
-              <a:t>2026/3/8</a:t>
+              <a:t>2026/3/12</a:t>
             </a:fld>
             <a:endParaRPr kumimoji="1" lang="ja-JP" altLang="en-US"/>
           </a:p>
@@ -3205,7 +3205,7 @@
           <a:p>
             <a:fld id="{46D3C7F6-BF65-453D-9C87-5BA16A0A8437}" type="datetimeFigureOut">
               <a:rPr kumimoji="1" lang="ja-JP" altLang="en-US" smtClean="0"/>
-              <a:t>2026/3/8</a:t>
+              <a:t>2026/3/12</a:t>
             </a:fld>
             <a:endParaRPr kumimoji="1" lang="ja-JP" altLang="en-US"/>
           </a:p>
@@ -3687,73 +3687,94 @@
           <a:chExt cx="0" cy="0"/>
         </a:xfrm>
       </p:grpSpPr>
-      <p:pic>
-        <p:nvPicPr>
-          <p:cNvPr id="18" name="図 17">
-            <a:extLst>
-              <a:ext uri="{FF2B5EF4-FFF2-40B4-BE49-F238E27FC236}">
-                <a16:creationId xmlns:a16="http://schemas.microsoft.com/office/drawing/2014/main" id="{1872711A-C017-5E6C-6347-C0BA3CEED00E}"/>
-              </a:ext>
-            </a:extLst>
-          </p:cNvPr>
-          <p:cNvPicPr>
-            <a:picLocks noChangeAspect="1"/>
-          </p:cNvPicPr>
+      <p:grpSp>
+        <p:nvGrpSpPr>
+          <p:cNvPr id="24" name="グループ化 23">
+            <a:extLst>
+              <a:ext uri="{FF2B5EF4-FFF2-40B4-BE49-F238E27FC236}">
+                <a16:creationId xmlns:a16="http://schemas.microsoft.com/office/drawing/2014/main" id="{95E73C08-FCEC-371D-5897-736DEB7E731B}"/>
+              </a:ext>
+            </a:extLst>
+          </p:cNvPr>
+          <p:cNvGrpSpPr/>
           <p:nvPr/>
-        </p:nvPicPr>
-        <p:blipFill>
-          <a:blip r:embed="rId2"/>
-          <a:srcRect b="54166"/>
-          <a:stretch>
-            <a:fillRect/>
-          </a:stretch>
-        </p:blipFill>
-        <p:spPr>
+        </p:nvGrpSpPr>
+        <p:grpSpPr>
           <a:xfrm>
             <a:off x="3056751" y="3964849"/>
             <a:ext cx="6078497" cy="2395471"/>
+            <a:chOff x="3056751" y="3964849"/>
+            <a:chExt cx="6078497" cy="2395471"/>
           </a:xfrm>
-          <a:prstGeom prst="rect">
-            <a:avLst/>
-          </a:prstGeom>
-        </p:spPr>
-      </p:pic>
+        </p:grpSpPr>
+        <p:pic>
+          <p:nvPicPr>
+            <p:cNvPr id="18" name="図 17">
+              <a:extLst>
+                <a:ext uri="{FF2B5EF4-FFF2-40B4-BE49-F238E27FC236}">
+                  <a16:creationId xmlns:a16="http://schemas.microsoft.com/office/drawing/2014/main" id="{1872711A-C017-5E6C-6347-C0BA3CEED00E}"/>
+                </a:ext>
+              </a:extLst>
+            </p:cNvPr>
+            <p:cNvPicPr>
+              <a:picLocks noChangeAspect="1"/>
+            </p:cNvPicPr>
+            <p:nvPr/>
+          </p:nvPicPr>
+          <p:blipFill>
+            <a:blip r:embed="rId2"/>
+            <a:srcRect b="54166"/>
+            <a:stretch>
+              <a:fillRect/>
+            </a:stretch>
+          </p:blipFill>
+          <p:spPr>
+            <a:xfrm>
+              <a:off x="3056751" y="3964849"/>
+              <a:ext cx="6078497" cy="2395471"/>
+            </a:xfrm>
+            <a:prstGeom prst="rect">
+              <a:avLst/>
+            </a:prstGeom>
+          </p:spPr>
+        </p:pic>
+        <p:pic>
+          <p:nvPicPr>
+            <p:cNvPr id="23" name="図 22">
+              <a:extLst>
+                <a:ext uri="{FF2B5EF4-FFF2-40B4-BE49-F238E27FC236}">
+                  <a16:creationId xmlns:a16="http://schemas.microsoft.com/office/drawing/2014/main" id="{A3DEEBE9-416D-B490-7BE3-DAA3DA46551B}"/>
+                </a:ext>
+              </a:extLst>
+            </p:cNvPr>
+            <p:cNvPicPr>
+              <a:picLocks noChangeAspect="1"/>
+            </p:cNvPicPr>
+            <p:nvPr/>
+          </p:nvPicPr>
+          <p:blipFill>
+            <a:blip r:embed="rId3"/>
+            <a:stretch>
+              <a:fillRect/>
+            </a:stretch>
+          </p:blipFill>
+          <p:spPr>
+            <a:xfrm>
+              <a:off x="7330129" y="5605250"/>
+              <a:ext cx="210623" cy="204241"/>
+            </a:xfrm>
+            <a:prstGeom prst="rect">
+              <a:avLst/>
+            </a:prstGeom>
+          </p:spPr>
+        </p:pic>
+      </p:grpSp>
       <p:pic>
         <p:nvPicPr>
           <p:cNvPr id="17" name="図 16">
             <a:extLst>
               <a:ext uri="{FF2B5EF4-FFF2-40B4-BE49-F238E27FC236}">
                 <a16:creationId xmlns:a16="http://schemas.microsoft.com/office/drawing/2014/main" id="{F66E85E0-2313-1834-E423-6F9DBB083431}"/>
-              </a:ext>
-            </a:extLst>
-          </p:cNvPr>
-          <p:cNvPicPr>
-            <a:picLocks noChangeAspect="1"/>
-          </p:cNvPicPr>
-          <p:nvPr/>
-        </p:nvPicPr>
-        <p:blipFill>
-          <a:blip r:embed="rId3"/>
-          <a:stretch>
-            <a:fillRect/>
-          </a:stretch>
-        </p:blipFill>
-        <p:spPr>
-          <a:xfrm>
-            <a:off x="8240644" y="688790"/>
-            <a:ext cx="3637873" cy="2454527"/>
-          </a:xfrm>
-          <a:prstGeom prst="rect">
-            <a:avLst/>
-          </a:prstGeom>
-        </p:spPr>
-      </p:pic>
-      <p:pic>
-        <p:nvPicPr>
-          <p:cNvPr id="16" name="Picture 6">
-            <a:extLst>
-              <a:ext uri="{FF2B5EF4-FFF2-40B4-BE49-F238E27FC236}">
-                <a16:creationId xmlns:a16="http://schemas.microsoft.com/office/drawing/2014/main" id="{088FE83F-DDF4-141E-0355-8A6A251CB333}"/>
               </a:ext>
             </a:extLst>
           </p:cNvPr>
@@ -3770,8 +3791,39 @@
         </p:blipFill>
         <p:spPr>
           <a:xfrm>
-            <a:off x="4161862" y="688790"/>
-            <a:ext cx="3916798" cy="2454527"/>
+            <a:off x="8255510" y="695415"/>
+            <a:ext cx="3503016" cy="2363537"/>
+          </a:xfrm>
+          <a:prstGeom prst="rect">
+            <a:avLst/>
+          </a:prstGeom>
+        </p:spPr>
+      </p:pic>
+      <p:pic>
+        <p:nvPicPr>
+          <p:cNvPr id="16" name="Picture 6">
+            <a:extLst>
+              <a:ext uri="{FF2B5EF4-FFF2-40B4-BE49-F238E27FC236}">
+                <a16:creationId xmlns:a16="http://schemas.microsoft.com/office/drawing/2014/main" id="{088FE83F-DDF4-141E-0355-8A6A251CB333}"/>
+              </a:ext>
+            </a:extLst>
+          </p:cNvPr>
+          <p:cNvPicPr>
+            <a:picLocks noChangeAspect="1"/>
+          </p:cNvPicPr>
+          <p:nvPr/>
+        </p:nvPicPr>
+        <p:blipFill>
+          <a:blip r:embed="rId5"/>
+          <a:srcRect t="3707"/>
+          <a:stretch>
+            <a:fillRect/>
+          </a:stretch>
+        </p:blipFill>
+        <p:spPr>
+          <a:xfrm>
+            <a:off x="4164281" y="689017"/>
+            <a:ext cx="3916798" cy="2363537"/>
           </a:xfrm>
           <a:prstGeom prst="rect">
             <a:avLst/>
@@ -3793,15 +3845,16 @@
           <p:nvPr/>
         </p:nvPicPr>
         <p:blipFill>
-          <a:blip r:embed="rId5"/>
+          <a:blip r:embed="rId6"/>
+          <a:srcRect t="5402"/>
           <a:stretch>
             <a:fillRect/>
           </a:stretch>
         </p:blipFill>
         <p:spPr>
           <a:xfrm>
-            <a:off x="323020" y="688790"/>
-            <a:ext cx="3676857" cy="2459420"/>
+            <a:off x="312993" y="695415"/>
+            <a:ext cx="3676857" cy="2326575"/>
           </a:xfrm>
           <a:prstGeom prst="rect">
             <a:avLst/>
@@ -3822,8 +3875,8 @@
         </p:nvSpPr>
         <p:spPr>
           <a:xfrm>
-            <a:off x="5512121" y="2951026"/>
-            <a:ext cx="1206253" cy="1654104"/>
+            <a:off x="5512121" y="2829339"/>
+            <a:ext cx="1206253" cy="1775791"/>
           </a:xfrm>
           <a:prstGeom prst="downArrow">
             <a:avLst>
@@ -3855,147 +3908,6 @@
           </a:p>
         </p:txBody>
       </p:sp>
-      <p:pic>
-        <p:nvPicPr>
-          <p:cNvPr id="9" name="Picture 2" descr="ファイル タイプ powerpoint の アイコン">
-            <a:extLst>
-              <a:ext uri="{FF2B5EF4-FFF2-40B4-BE49-F238E27FC236}">
-                <a16:creationId xmlns:a16="http://schemas.microsoft.com/office/drawing/2014/main" id="{41AD53BF-1911-5B33-2C9A-A57262493B9F}"/>
-              </a:ext>
-            </a:extLst>
-          </p:cNvPr>
-          <p:cNvPicPr>
-            <a:picLocks noChangeAspect="1" noChangeArrowheads="1"/>
-          </p:cNvPicPr>
-          <p:nvPr/>
-        </p:nvPicPr>
-        <p:blipFill>
-          <a:blip r:embed="rId6">
-            <a:extLst>
-              <a:ext uri="{28A0092B-C50C-407E-A947-70E740481C1C}">
-                <a14:useLocalDpi xmlns:a14="http://schemas.microsoft.com/office/drawing/2010/main" val="0"/>
-              </a:ext>
-            </a:extLst>
-          </a:blip>
-          <a:srcRect/>
-          <a:stretch>
-            <a:fillRect/>
-          </a:stretch>
-        </p:blipFill>
-        <p:spPr bwMode="auto">
-          <a:xfrm>
-            <a:off x="3130983" y="688790"/>
-            <a:ext cx="868895" cy="868895"/>
-          </a:xfrm>
-          <a:prstGeom prst="rect">
-            <a:avLst/>
-          </a:prstGeom>
-          <a:noFill/>
-          <a:extLst>
-            <a:ext uri="{909E8E84-426E-40DD-AFC4-6F175D3DCCD1}">
-              <a14:hiddenFill xmlns:a14="http://schemas.microsoft.com/office/drawing/2010/main">
-                <a:solidFill>
-                  <a:srgbClr val="FFFFFF"/>
-                </a:solidFill>
-              </a14:hiddenFill>
-            </a:ext>
-          </a:extLst>
-        </p:spPr>
-      </p:pic>
-      <p:pic>
-        <p:nvPicPr>
-          <p:cNvPr id="10" name="Picture 4">
-            <a:extLst>
-              <a:ext uri="{FF2B5EF4-FFF2-40B4-BE49-F238E27FC236}">
-                <a16:creationId xmlns:a16="http://schemas.microsoft.com/office/drawing/2014/main" id="{DF8EEC80-AAFD-205B-36F2-6088398CCBC5}"/>
-              </a:ext>
-            </a:extLst>
-          </p:cNvPr>
-          <p:cNvPicPr>
-            <a:picLocks noChangeAspect="1" noChangeArrowheads="1"/>
-          </p:cNvPicPr>
-          <p:nvPr/>
-        </p:nvPicPr>
-        <p:blipFill>
-          <a:blip r:embed="rId7">
-            <a:extLst>
-              <a:ext uri="{28A0092B-C50C-407E-A947-70E740481C1C}">
-                <a14:useLocalDpi xmlns:a14="http://schemas.microsoft.com/office/drawing/2010/main" val="0"/>
-              </a:ext>
-            </a:extLst>
-          </a:blip>
-          <a:srcRect/>
-          <a:stretch>
-            <a:fillRect/>
-          </a:stretch>
-        </p:blipFill>
-        <p:spPr bwMode="auto">
-          <a:xfrm>
-            <a:off x="7044117" y="750275"/>
-            <a:ext cx="745924" cy="745924"/>
-          </a:xfrm>
-          <a:prstGeom prst="rect">
-            <a:avLst/>
-          </a:prstGeom>
-          <a:noFill/>
-          <a:extLst>
-            <a:ext uri="{909E8E84-426E-40DD-AFC4-6F175D3DCCD1}">
-              <a14:hiddenFill xmlns:a14="http://schemas.microsoft.com/office/drawing/2010/main">
-                <a:solidFill>
-                  <a:srgbClr val="FFFFFF"/>
-                </a:solidFill>
-              </a14:hiddenFill>
-            </a:ext>
-          </a:extLst>
-        </p:spPr>
-      </p:pic>
-      <p:pic>
-        <p:nvPicPr>
-          <p:cNvPr id="11" name="Picture 6">
-            <a:extLst>
-              <a:ext uri="{FF2B5EF4-FFF2-40B4-BE49-F238E27FC236}">
-                <a16:creationId xmlns:a16="http://schemas.microsoft.com/office/drawing/2014/main" id="{5A0BFB8D-54C0-30F4-21F6-1622F5B0E1A0}"/>
-              </a:ext>
-            </a:extLst>
-          </p:cNvPr>
-          <p:cNvPicPr>
-            <a:picLocks noChangeAspect="1" noChangeArrowheads="1"/>
-          </p:cNvPicPr>
-          <p:nvPr/>
-        </p:nvPicPr>
-        <p:blipFill>
-          <a:blip r:embed="rId8">
-            <a:extLst>
-              <a:ext uri="{28A0092B-C50C-407E-A947-70E740481C1C}">
-                <a14:useLocalDpi xmlns:a14="http://schemas.microsoft.com/office/drawing/2010/main" val="0"/>
-              </a:ext>
-            </a:extLst>
-          </a:blip>
-          <a:srcRect/>
-          <a:stretch>
-            <a:fillRect/>
-          </a:stretch>
-        </p:blipFill>
-        <p:spPr bwMode="auto">
-          <a:xfrm>
-            <a:off x="11078932" y="738393"/>
-            <a:ext cx="695316" cy="695316"/>
-          </a:xfrm>
-          <a:prstGeom prst="rect">
-            <a:avLst/>
-          </a:prstGeom>
-          <a:noFill/>
-          <a:extLst>
-            <a:ext uri="{909E8E84-426E-40DD-AFC4-6F175D3DCCD1}">
-              <a14:hiddenFill xmlns:a14="http://schemas.microsoft.com/office/drawing/2010/main">
-                <a:solidFill>
-                  <a:srgbClr val="FFFFFF"/>
-                </a:solidFill>
-              </a14:hiddenFill>
-            </a:ext>
-          </a:extLst>
-        </p:spPr>
-      </p:pic>
       <p:sp>
         <p:nvSpPr>
           <p:cNvPr id="12" name="四角形: 角度付き 11">
@@ -4209,6 +4121,231 @@
               <a:solidFill>
                 <a:schemeClr val="tx1"/>
               </a:solidFill>
+              <a:latin typeface="CaskaydiaCove NF" panose="02000009000000000000" pitchFamily="50" charset="0"/>
+              <a:cs typeface="CaskaydiaCove NF" panose="02000009000000000000" pitchFamily="50" charset="0"/>
+            </a:endParaRPr>
+          </a:p>
+        </p:txBody>
+      </p:sp>
+      <p:sp>
+        <p:nvSpPr>
+          <p:cNvPr id="2" name="正方形/長方形 1">
+            <a:extLst>
+              <a:ext uri="{FF2B5EF4-FFF2-40B4-BE49-F238E27FC236}">
+                <a16:creationId xmlns:a16="http://schemas.microsoft.com/office/drawing/2014/main" id="{25726B72-3670-08B2-511B-3E89B89282A5}"/>
+              </a:ext>
+            </a:extLst>
+          </p:cNvPr>
+          <p:cNvSpPr/>
+          <p:nvPr/>
+        </p:nvSpPr>
+        <p:spPr>
+          <a:xfrm>
+            <a:off x="2307866" y="695416"/>
+            <a:ext cx="1678608" cy="431020"/>
+          </a:xfrm>
+          <a:prstGeom prst="rect">
+            <a:avLst/>
+          </a:prstGeom>
+        </p:spPr>
+        <p:style>
+          <a:lnRef idx="1">
+            <a:schemeClr val="accent4"/>
+          </a:lnRef>
+          <a:fillRef idx="3">
+            <a:schemeClr val="accent4"/>
+          </a:fillRef>
+          <a:effectRef idx="2">
+            <a:schemeClr val="accent4"/>
+          </a:effectRef>
+          <a:fontRef idx="minor">
+            <a:schemeClr val="lt1"/>
+          </a:fontRef>
+        </p:style>
+        <p:txBody>
+          <a:bodyPr rtlCol="0" anchor="ctr"/>
+          <a:lstStyle/>
+          <a:p>
+            <a:pPr algn="ctr"/>
+            <a:r>
+              <a:rPr kumimoji="1" lang="en-US" altLang="ja-JP" dirty="0">
+                <a:latin typeface="CaskaydiaCove NF" panose="02000009000000000000" pitchFamily="50" charset="0"/>
+                <a:ea typeface="CaskaydiaCove NF" panose="02000009000000000000" pitchFamily="50" charset="0"/>
+                <a:cs typeface="CaskaydiaCove NF" panose="02000009000000000000" pitchFamily="50" charset="0"/>
+              </a:rPr>
+              <a:t>Slide</a:t>
+            </a:r>
+            <a:endParaRPr kumimoji="1" lang="ja-JP" altLang="en-US" dirty="0">
+              <a:latin typeface="CaskaydiaCove NF" panose="02000009000000000000" pitchFamily="50" charset="0"/>
+              <a:cs typeface="CaskaydiaCove NF" panose="02000009000000000000" pitchFamily="50" charset="0"/>
+            </a:endParaRPr>
+          </a:p>
+        </p:txBody>
+      </p:sp>
+      <p:sp>
+        <p:nvSpPr>
+          <p:cNvPr id="9" name="正方形/長方形 8">
+            <a:extLst>
+              <a:ext uri="{FF2B5EF4-FFF2-40B4-BE49-F238E27FC236}">
+                <a16:creationId xmlns:a16="http://schemas.microsoft.com/office/drawing/2014/main" id="{6DCCAB57-800B-5EB9-3B3A-D86333D8F350}"/>
+              </a:ext>
+            </a:extLst>
+          </p:cNvPr>
+          <p:cNvSpPr/>
+          <p:nvPr/>
+        </p:nvSpPr>
+        <p:spPr>
+          <a:xfrm>
+            <a:off x="6400052" y="695416"/>
+            <a:ext cx="1678608" cy="431020"/>
+          </a:xfrm>
+          <a:prstGeom prst="rect">
+            <a:avLst/>
+          </a:prstGeom>
+        </p:spPr>
+        <p:style>
+          <a:lnRef idx="1">
+            <a:schemeClr val="accent4"/>
+          </a:lnRef>
+          <a:fillRef idx="3">
+            <a:schemeClr val="accent4"/>
+          </a:fillRef>
+          <a:effectRef idx="2">
+            <a:schemeClr val="accent4"/>
+          </a:effectRef>
+          <a:fontRef idx="minor">
+            <a:schemeClr val="lt1"/>
+          </a:fontRef>
+        </p:style>
+        <p:txBody>
+          <a:bodyPr rtlCol="0" anchor="ctr"/>
+          <a:lstStyle/>
+          <a:p>
+            <a:pPr algn="ctr"/>
+            <a:r>
+              <a:rPr kumimoji="1" lang="en-US" altLang="ja-JP" dirty="0">
+                <a:latin typeface="CaskaydiaCove NF" panose="02000009000000000000" pitchFamily="50" charset="0"/>
+                <a:ea typeface="CaskaydiaCove NF" panose="02000009000000000000" pitchFamily="50" charset="0"/>
+                <a:cs typeface="CaskaydiaCove NF" panose="02000009000000000000" pitchFamily="50" charset="0"/>
+              </a:rPr>
+              <a:t>Notes</a:t>
+            </a:r>
+            <a:endParaRPr kumimoji="1" lang="ja-JP" altLang="en-US" dirty="0">
+              <a:latin typeface="CaskaydiaCove NF" panose="02000009000000000000" pitchFamily="50" charset="0"/>
+              <a:cs typeface="CaskaydiaCove NF" panose="02000009000000000000" pitchFamily="50" charset="0"/>
+            </a:endParaRPr>
+          </a:p>
+        </p:txBody>
+      </p:sp>
+      <p:sp>
+        <p:nvSpPr>
+          <p:cNvPr id="10" name="正方形/長方形 9">
+            <a:extLst>
+              <a:ext uri="{FF2B5EF4-FFF2-40B4-BE49-F238E27FC236}">
+                <a16:creationId xmlns:a16="http://schemas.microsoft.com/office/drawing/2014/main" id="{1652F407-CDE8-A078-C4FB-663DF966CE42}"/>
+              </a:ext>
+            </a:extLst>
+          </p:cNvPr>
+          <p:cNvSpPr/>
+          <p:nvPr/>
+        </p:nvSpPr>
+        <p:spPr>
+          <a:xfrm>
+            <a:off x="10079918" y="695416"/>
+            <a:ext cx="1678608" cy="431020"/>
+          </a:xfrm>
+          <a:prstGeom prst="rect">
+            <a:avLst/>
+          </a:prstGeom>
+        </p:spPr>
+        <p:style>
+          <a:lnRef idx="1">
+            <a:schemeClr val="accent4"/>
+          </a:lnRef>
+          <a:fillRef idx="3">
+            <a:schemeClr val="accent4"/>
+          </a:fillRef>
+          <a:effectRef idx="2">
+            <a:schemeClr val="accent4"/>
+          </a:effectRef>
+          <a:fontRef idx="minor">
+            <a:schemeClr val="lt1"/>
+          </a:fontRef>
+        </p:style>
+        <p:txBody>
+          <a:bodyPr rtlCol="0" anchor="ctr"/>
+          <a:lstStyle/>
+          <a:p>
+            <a:pPr algn="ctr"/>
+            <a:r>
+              <a:rPr kumimoji="1" lang="en-US" altLang="ja-JP" dirty="0">
+                <a:latin typeface="CaskaydiaCove NF" panose="02000009000000000000" pitchFamily="50" charset="0"/>
+                <a:cs typeface="CaskaydiaCove NF" panose="02000009000000000000" pitchFamily="50" charset="0"/>
+              </a:rPr>
+              <a:t>Web</a:t>
+            </a:r>
+            <a:endParaRPr kumimoji="1" lang="ja-JP" altLang="en-US" dirty="0">
+              <a:latin typeface="CaskaydiaCove NF" panose="02000009000000000000" pitchFamily="50" charset="0"/>
+              <a:cs typeface="CaskaydiaCove NF" panose="02000009000000000000" pitchFamily="50" charset="0"/>
+            </a:endParaRPr>
+          </a:p>
+        </p:txBody>
+      </p:sp>
+      <p:sp>
+        <p:nvSpPr>
+          <p:cNvPr id="19" name="正方形/長方形 18">
+            <a:extLst>
+              <a:ext uri="{FF2B5EF4-FFF2-40B4-BE49-F238E27FC236}">
+                <a16:creationId xmlns:a16="http://schemas.microsoft.com/office/drawing/2014/main" id="{F5DE563D-99E0-97BF-A8F3-353AF9EE2136}"/>
+              </a:ext>
+            </a:extLst>
+          </p:cNvPr>
+          <p:cNvSpPr/>
+          <p:nvPr/>
+        </p:nvSpPr>
+        <p:spPr>
+          <a:xfrm>
+            <a:off x="7432450" y="3964850"/>
+            <a:ext cx="1678608" cy="431020"/>
+          </a:xfrm>
+          <a:prstGeom prst="rect">
+            <a:avLst/>
+          </a:prstGeom>
+        </p:spPr>
+        <p:style>
+          <a:lnRef idx="1">
+            <a:schemeClr val="accent4"/>
+          </a:lnRef>
+          <a:fillRef idx="3">
+            <a:schemeClr val="accent4"/>
+          </a:fillRef>
+          <a:effectRef idx="2">
+            <a:schemeClr val="accent4"/>
+          </a:effectRef>
+          <a:fontRef idx="minor">
+            <a:schemeClr val="lt1"/>
+          </a:fontRef>
+        </p:style>
+        <p:txBody>
+          <a:bodyPr rtlCol="0" anchor="ctr"/>
+          <a:lstStyle/>
+          <a:p>
+            <a:pPr algn="ctr"/>
+            <a:r>
+              <a:rPr lang="en-US" altLang="ja-JP" dirty="0">
+                <a:latin typeface="CaskaydiaCove NF" panose="02000009000000000000" pitchFamily="50" charset="0"/>
+                <a:cs typeface="CaskaydiaCove NF" panose="02000009000000000000" pitchFamily="50" charset="0"/>
+              </a:rPr>
+              <a:t>E</a:t>
+            </a:r>
+            <a:r>
+              <a:rPr kumimoji="1" lang="en-US" altLang="ja-JP" dirty="0">
+                <a:latin typeface="CaskaydiaCove NF" panose="02000009000000000000" pitchFamily="50" charset="0"/>
+                <a:cs typeface="CaskaydiaCove NF" panose="02000009000000000000" pitchFamily="50" charset="0"/>
+              </a:rPr>
+              <a:t>xplorer</a:t>
+            </a:r>
+            <a:endParaRPr kumimoji="1" lang="ja-JP" altLang="en-US" dirty="0">
               <a:latin typeface="CaskaydiaCove NF" panose="02000009000000000000" pitchFamily="50" charset="0"/>
               <a:cs typeface="CaskaydiaCove NF" panose="02000009000000000000" pitchFamily="50" charset="0"/>
             </a:endParaRPr>

</xml_diff>